<commit_message>
Package the REIN submission artifacts
</commit_message>
<xml_diff>
--- a/output/presentation/REIN-Hackathon-Deck.pptx
+++ b/output/presentation/REIN-Hackathon-Deck.pptx
@@ -5019,7 +5019,7 @@
         </p:nvPicPr>
         <p:blipFill>
           <a:blip r:embed="rId3"/>
-          <a:srcRect l="0" r="0" t="8941" b="8941"/>
+          <a:srcRect l="0" r="0" t="8916" b="8916"/>
           <a:stretch/>
         </p:blipFill>
         <p:spPr>
@@ -8695,7 +8695,7 @@
                 <a:ea typeface="Cascadia Mono" pitchFamily="34" charset="-122"/>
                 <a:cs typeface="Cascadia Mono" pitchFamily="34" charset="-120"/>
               </a:rPr>
-              <a:t>2NuicT57mQD1Uu5yumPnubCkrdSVHQUegbxLEBsDtpdVTTjw5dTdyB3QpH9t7VZLGnyQyNV9DySA9xWMY9YMpArw</a:t>
+              <a:t>NoNGYPThfsy8jx43CvHBeVwXx6Cm5T9eLLNuM2JNEKfBSYnZLveQThxeio9Y7Divs9CEpg6TXFyUrjPBAEpQyrd</a:t>
             </a:r>
             <a:endParaRPr lang="en-US" sz="710" dirty="0"/>
           </a:p>
@@ -8878,7 +8878,7 @@
                 <a:ea typeface="Cascadia Mono" pitchFamily="34" charset="-122"/>
                 <a:cs typeface="Cascadia Mono" pitchFamily="34" charset="-120"/>
               </a:rPr>
-              <a:t>3vpyu3DsDvDT2m71kj3Pt5GQ4Ba2jQVYkuFhWL9eTUgiVXwpMiQKpbtjSPKaV5J5K3cpff6726kXT8p5Ui6gbcGR</a:t>
+              <a:t>4Pw18BGdsvv7zo9WYsMXi3p5cCxhgrv5H3mNpa9hyyPopuAkDx18r48WcFor6CSEnNukbVCdJpgwPDXKrsAk7cbj</a:t>
             </a:r>
             <a:endParaRPr lang="en-US" sz="710" dirty="0"/>
           </a:p>
@@ -8956,7 +8956,7 @@
                 <a:ea typeface="Cascadia Mono" pitchFamily="34" charset="-122"/>
                 <a:cs typeface="Cascadia Mono" pitchFamily="34" charset="-120"/>
               </a:rPr>
-              <a:t>48</a:t>
+              <a:t>55</a:t>
             </a:r>
             <a:endParaRPr lang="en-US" sz="2700" dirty="0"/>
           </a:p>

</xml_diff>

<commit_message>
Refine public product copy
</commit_message>
<xml_diff>
--- a/output/presentation/REIN-Hackathon-Deck.pptx
+++ b/output/presentation/REIN-Hackathon-Deck.pptx
@@ -1817,7 +1817,7 @@
                 <a:ea typeface="Noto Sans KR" pitchFamily="34" charset="-122"/>
                 <a:cs typeface="Noto Sans KR" pitchFamily="34" charset="-120"/>
               </a:rPr>
-              <a:t>목표와 예산만 지정하면, 선택·결제·근거 보고서까지 한 번에.</a:t>
+              <a:t>목표와 예산을 받으면 데이터를 고르고, 결제한 뒤 근거와 영수증을 남깁니다.</a:t>
             </a:r>
             <a:endParaRPr lang="en-US" sz="1500" dirty="0"/>
           </a:p>
@@ -2400,7 +2400,7 @@
                 <a:ea typeface="Noto Sans KR" pitchFamily="34" charset="-122"/>
                 <a:cs typeface="Noto Sans KR" pitchFamily="34" charset="-120"/>
               </a:rPr>
-              <a:t>AI가 결제할수록, 답변보다 구매 통제가 먼저입니다.</a:t>
+              <a:t>데이터를 고르는 모델에게 결제 권한까지 맡길 수는 없습니다.</a:t>
             </a:r>
             <a:endParaRPr lang="en-US" sz="2700" dirty="0"/>
           </a:p>
@@ -2439,7 +2439,7 @@
                 <a:ea typeface="Noto Sans KR" pitchFamily="34" charset="-122"/>
                 <a:cs typeface="Noto Sans KR" pitchFamily="34" charset="-120"/>
               </a:rPr>
-              <a:t>Target: 유료 외부 데이터를 쓰는 리서치·AI 운영팀</a:t>
+              <a:t>대상: 유료 외부 데이터를 쓰는 리서치·AI 운영팀</a:t>
             </a:r>
             <a:endParaRPr lang="en-US" sz="1150" dirty="0"/>
           </a:p>
@@ -2567,7 +2567,7 @@
                 <a:ea typeface="Cascadia Mono" pitchFamily="34" charset="-122"/>
                 <a:cs typeface="Cascadia Mono" pitchFamily="34" charset="-120"/>
               </a:rPr>
-              <a:t>WHY</a:t>
+              <a:t>선택 근거</a:t>
             </a:r>
             <a:endParaRPr lang="en-US" sz="700" dirty="0"/>
           </a:p>
@@ -2668,7 +2668,7 @@
                 <a:ea typeface="Noto Sans KR" pitchFamily="34" charset="-122"/>
                 <a:cs typeface="Noto Sans KR" pitchFamily="34" charset="-120"/>
               </a:rPr>
-              <a:t>추천 문장만으로는 관련성과 가격을 감사할 수 없습니다.</a:t>
+              <a:t>추천 문장만으로는 관련성과 가격을 대조하기 어렵습니다.</a:t>
             </a:r>
             <a:endParaRPr lang="en-US" sz="1000" dirty="0"/>
           </a:p>
@@ -2773,7 +2773,7 @@
                 <a:ea typeface="Cascadia Mono" pitchFamily="34" charset="-122"/>
                 <a:cs typeface="Cascadia Mono" pitchFamily="34" charset="-120"/>
               </a:rPr>
-              <a:t>LIMIT</a:t>
+              <a:t>정책</a:t>
             </a:r>
             <a:endParaRPr lang="en-US" sz="700" dirty="0"/>
           </a:p>
@@ -2835,7 +2835,7 @@
                 <a:ea typeface="Noto Sans KR" pitchFamily="34" charset="-122"/>
                 <a:cs typeface="Noto Sans KR" pitchFamily="34" charset="-120"/>
               </a:rPr>
-              <a:t>상한을 정말 지켰는가?</a:t>
+              <a:t>예산과 자산 정책을 지켰는가?</a:t>
             </a:r>
             <a:endParaRPr lang="en-US" sz="1700" dirty="0"/>
           </a:p>
@@ -2874,7 +2874,7 @@
                 <a:ea typeface="Noto Sans KR" pitchFamily="34" charset="-122"/>
                 <a:cs typeface="Noto Sans KR" pitchFamily="34" charset="-120"/>
               </a:rPr>
-              <a:t>모델 출력만 믿으면 URL·자산·금액이 정책을 벗어날 수 있습니다.</a:t>
+              <a:t>모델 출력만으로 URL·자산·금액을 제한할 수 없습니다.</a:t>
             </a:r>
             <a:endParaRPr lang="en-US" sz="1000" dirty="0"/>
           </a:p>
@@ -2979,7 +2979,7 @@
                 <a:ea typeface="Cascadia Mono" pitchFamily="34" charset="-122"/>
                 <a:cs typeface="Cascadia Mono" pitchFamily="34" charset="-120"/>
               </a:rPr>
-              <a:t>PROOF</a:t>
+              <a:t>정산</a:t>
             </a:r>
             <a:endParaRPr lang="en-US" sz="700" dirty="0"/>
           </a:p>
@@ -3041,7 +3041,7 @@
                 <a:ea typeface="Noto Sans KR" pitchFamily="34" charset="-122"/>
                 <a:cs typeface="Noto Sans KR" pitchFamily="34" charset="-120"/>
               </a:rPr>
-              <a:t>정말 한 번만 결제했는가?</a:t>
+              <a:t>중복 결제 없이 정산됐는가?</a:t>
             </a:r>
             <a:endParaRPr lang="en-US" sz="1700" dirty="0"/>
           </a:p>
@@ -3080,7 +3080,7 @@
                 <a:ea typeface="Noto Sans KR" pitchFamily="34" charset="-122"/>
                 <a:cs typeface="Noto Sans KR" pitchFamily="34" charset="-120"/>
               </a:rPr>
-              <a:t>timeout과 retry는 이중 결제 또는 가짜 완료 표시를 만듭니다.</a:t>
+              <a:t>시간 초과 뒤 재시도는 중복 결제나 잘못된 완료 처리를 만들 수 있습니다.</a:t>
             </a:r>
             <a:endParaRPr lang="en-US" sz="1000" dirty="0"/>
           </a:p>
@@ -3119,7 +3119,7 @@
                 <a:ea typeface="Cascadia Mono" pitchFamily="34" charset="-122"/>
                 <a:cs typeface="Cascadia Mono" pitchFamily="34" charset="-120"/>
               </a:rPr>
-              <a:t>REIN의 답</a:t>
+              <a:t>REIN이 남기는 것</a:t>
             </a:r>
             <a:endParaRPr lang="en-US" sz="800" dirty="0"/>
           </a:p>
@@ -3158,7 +3158,7 @@
                 <a:ea typeface="Noto Sans KR" pitchFamily="34" charset="-122"/>
                 <a:cs typeface="Noto Sans KR" pitchFamily="34" charset="-120"/>
               </a:rPr>
-              <a:t>선택 이유 + deterministic policy + 공개 영수증을 하나의 run에 묶습니다.</a:t>
+              <a:t>선택 이유, 코드 정책, Explorer 영수증을 실행 기록 하나에 묶습니다.</a:t>
             </a:r>
             <a:endParaRPr lang="en-US" sz="1600" dirty="0"/>
           </a:p>
@@ -3440,46 +3440,63 @@
                 <a:ea typeface="Noto Sans KR" pitchFamily="34" charset="-122"/>
                 <a:cs typeface="Noto Sans KR" pitchFamily="34" charset="-120"/>
               </a:rPr>
-              <a:t>사람은 목표와 상한을 정하고, 에이전트는 조달을 완결합니다.</a:t>
+              <a:t>사용자는 목표와 상한만 정합니다.</a:t>
             </a:r>
             <a:endParaRPr lang="en-US" sz="2700" dirty="0"/>
           </a:p>
-        </p:txBody>
-      </p:sp>
-      <p:sp>
-        <p:nvSpPr>
-          <p:cNvPr id="6" name="Text 3"/>
-          <p:cNvSpPr/>
-          <p:nvPr/>
-        </p:nvSpPr>
-        <p:spPr>
-          <a:xfrm>
-            <a:off x="640080" y="1783080"/>
-            <a:ext cx="10744200" cy="347472"/>
-          </a:xfrm>
-          <a:prstGeom prst="rect">
-            <a:avLst/>
-          </a:prstGeom>
-          <a:noFill/>
-          <a:ln/>
-        </p:spPr>
-        <p:txBody>
-          <a:bodyPr wrap="square" lIns="0" tIns="0" rIns="0" bIns="0" rtlCol="0" anchor="ctr"/>
-          <a:lstStyle/>
-          <a:p>
-            <a:pPr indent="0" marL="0">
-              <a:buNone/>
-            </a:pPr>
-            <a:r>
-              <a:rPr lang="en-US" sz="1150" dirty="0">
-                <a:solidFill>
-                  <a:srgbClr val="52645D"/>
+          <a:p>
+            <a:pPr indent="0" marL="0">
+              <a:buNone/>
+            </a:pPr>
+            <a:r>
+              <a:rPr lang="en-US" sz="2700" b="1" dirty="0">
+                <a:solidFill>
+                  <a:srgbClr val="111A16"/>
                 </a:solidFill>
                 <a:latin typeface="Noto Sans KR" pitchFamily="34" charset="0"/>
                 <a:ea typeface="Noto Sans KR" pitchFamily="34" charset="-122"/>
                 <a:cs typeface="Noto Sans KR" pitchFamily="34" charset="-120"/>
               </a:rPr>
-              <a:t>기본 데모: 0.003 테스트 USDC로 SOL·ETH 시장과 개발 모멘텀 비교</a:t>
+              <a:t>REIN이 선택·검사·결제·보고를 수행합니다.</a:t>
+            </a:r>
+            <a:endParaRPr lang="en-US" sz="2700" dirty="0"/>
+          </a:p>
+        </p:txBody>
+      </p:sp>
+      <p:sp>
+        <p:nvSpPr>
+          <p:cNvPr id="6" name="Text 3"/>
+          <p:cNvSpPr/>
+          <p:nvPr/>
+        </p:nvSpPr>
+        <p:spPr>
+          <a:xfrm>
+            <a:off x="640080" y="1783080"/>
+            <a:ext cx="10744200" cy="347472"/>
+          </a:xfrm>
+          <a:prstGeom prst="rect">
+            <a:avLst/>
+          </a:prstGeom>
+          <a:noFill/>
+          <a:ln/>
+        </p:spPr>
+        <p:txBody>
+          <a:bodyPr wrap="square" lIns="0" tIns="0" rIns="0" bIns="0" rtlCol="0" anchor="ctr"/>
+          <a:lstStyle/>
+          <a:p>
+            <a:pPr indent="0" marL="0">
+              <a:buNone/>
+            </a:pPr>
+            <a:r>
+              <a:rPr lang="en-US" sz="1150" dirty="0">
+                <a:solidFill>
+                  <a:srgbClr val="52645D"/>
+                </a:solidFill>
+                <a:latin typeface="Noto Sans KR" pitchFamily="34" charset="0"/>
+                <a:ea typeface="Noto Sans KR" pitchFamily="34" charset="-122"/>
+                <a:cs typeface="Noto Sans KR" pitchFamily="34" charset="-120"/>
+              </a:rPr>
+              <a:t>기본 실행: 0.003 Devnet USDC로 SOL·ETH 시장과 개발 모멘텀 비교</a:t>
             </a:r>
             <a:endParaRPr lang="en-US" sz="1150" dirty="0"/>
           </a:p>
@@ -3649,7 +3666,7 @@
                 <a:ea typeface="Noto Sans KR" pitchFamily="34" charset="-122"/>
                 <a:cs typeface="Noto Sans KR" pitchFamily="34" charset="-120"/>
               </a:rPr>
-              <a:t>조사 주문</a:t>
+              <a:t>조사 목표</a:t>
             </a:r>
             <a:endParaRPr lang="en-US" sz="1500" dirty="0"/>
           </a:p>
@@ -3688,7 +3705,7 @@
                 <a:ea typeface="Noto Sans KR" pitchFamily="34" charset="-122"/>
                 <a:cs typeface="Noto Sans KR" pitchFamily="34" charset="-120"/>
               </a:rPr>
-              <a:t>목표 + 3000 atomic</a:t>
+              <a:t>목표 + 0.003 USDC</a:t>
             </a:r>
             <a:endParaRPr lang="en-US" sz="950" dirty="0"/>
           </a:p>
@@ -3874,7 +3891,7 @@
                 <a:ea typeface="Noto Sans KR" pitchFamily="34" charset="-122"/>
                 <a:cs typeface="Noto Sans KR" pitchFamily="34" charset="-120"/>
               </a:rPr>
-              <a:t>Market 1000</a:t>
+              <a:t>시장 0.001</a:t>
             </a:r>
             <a:endParaRPr lang="en-US" sz="950" dirty="0"/>
           </a:p>
@@ -3891,7 +3908,7 @@
                 <a:ea typeface="Noto Sans KR" pitchFamily="34" charset="-122"/>
                 <a:cs typeface="Noto Sans KR" pitchFamily="34" charset="-120"/>
               </a:rPr>
-              <a:t>GitHub 2000</a:t>
+              <a:t>GitHub 0.002</a:t>
             </a:r>
             <a:endParaRPr lang="en-US" sz="950" dirty="0"/>
           </a:p>
@@ -4038,7 +4055,7 @@
                 <a:ea typeface="Noto Sans KR" pitchFamily="34" charset="-122"/>
                 <a:cs typeface="Noto Sans KR" pitchFamily="34" charset="-120"/>
               </a:rPr>
-              <a:t>서명 전 승인</a:t>
+              <a:t>결제 전 검사</a:t>
             </a:r>
             <a:endParaRPr lang="en-US" sz="1500" dirty="0"/>
           </a:p>
@@ -4094,7 +4111,7 @@
                 <a:ea typeface="Noto Sans KR" pitchFamily="34" charset="-122"/>
                 <a:cs typeface="Noto Sans KR" pitchFamily="34" charset="-120"/>
               </a:rPr>
-              <a:t>상한 재검증</a:t>
+              <a:t>상한 확인</a:t>
             </a:r>
             <a:endParaRPr lang="en-US" sz="950" dirty="0"/>
           </a:p>
@@ -4297,7 +4314,7 @@
                 <a:ea typeface="Noto Sans KR" pitchFamily="34" charset="-122"/>
                 <a:cs typeface="Noto Sans KR" pitchFamily="34" charset="-120"/>
               </a:rPr>
-              <a:t>2 transactions</a:t>
+              <a:t>거래 2건</a:t>
             </a:r>
             <a:endParaRPr lang="en-US" sz="950" dirty="0"/>
           </a:p>
@@ -4381,7 +4398,7 @@
                 <a:ea typeface="Cascadia Mono" pitchFamily="34" charset="-122"/>
                 <a:cs typeface="Cascadia Mono" pitchFamily="34" charset="-120"/>
               </a:rPr>
-              <a:t>PROVE</a:t>
+              <a:t>RESULT</a:t>
             </a:r>
             <a:endParaRPr lang="en-US" sz="750" dirty="0"/>
           </a:p>
@@ -4420,7 +4437,7 @@
                 <a:ea typeface="Noto Sans KR" pitchFamily="34" charset="-122"/>
                 <a:cs typeface="Noto Sans KR" pitchFamily="34" charset="-120"/>
               </a:rPr>
-              <a:t>근거 보고서</a:t>
+              <a:t>결과 기록</a:t>
             </a:r>
             <a:endParaRPr lang="en-US" sz="1500" dirty="0"/>
           </a:p>
@@ -4459,7 +4476,7 @@
                 <a:ea typeface="Noto Sans KR" pitchFamily="34" charset="-122"/>
                 <a:cs typeface="Noto Sans KR" pitchFamily="34" charset="-120"/>
               </a:rPr>
-              <a:t>snapshot + receipt</a:t>
+              <a:t>스냅샷 + 영수증</a:t>
             </a:r>
             <a:endParaRPr lang="en-US" sz="950" dirty="0"/>
           </a:p>
@@ -4476,7 +4493,7 @@
                 <a:ea typeface="Noto Sans KR" pitchFamily="34" charset="-122"/>
                 <a:cs typeface="Noto Sans KR" pitchFamily="34" charset="-120"/>
               </a:rPr>
-              <a:t>+ caveat</a:t>
+              <a:t>+ 데이터 한계</a:t>
             </a:r>
             <a:endParaRPr lang="en-US" sz="950" dirty="0"/>
           </a:p>
@@ -4581,7 +4598,7 @@
                 <a:ea typeface="Noto Sans KR" pitchFamily="34" charset="-122"/>
                 <a:cs typeface="Noto Sans KR" pitchFamily="34" charset="-120"/>
               </a:rPr>
-              <a:t>상품 · 관련성 · 가격 · 짧은 선택 이유</a:t>
+              <a:t>상품 · 관련성 · 가격 · 선택 이유</a:t>
             </a:r>
             <a:endParaRPr lang="en-US" sz="1300" dirty="0"/>
           </a:p>
@@ -4620,7 +4637,7 @@
                 <a:ea typeface="Cascadia Mono" pitchFamily="34" charset="-122"/>
                 <a:cs typeface="Cascadia Mono" pitchFamily="34" charset="-120"/>
               </a:rPr>
-              <a:t>NOT EXPOSED</a:t>
+              <a:t>모델 권한 밖</a:t>
             </a:r>
             <a:endParaRPr lang="en-US" sz="750" dirty="0"/>
           </a:p>
@@ -4659,7 +4676,7 @@
                 <a:ea typeface="Noto Sans KR" pitchFamily="34" charset="-122"/>
                 <a:cs typeface="Noto Sans KR" pitchFamily="34" charset="-120"/>
               </a:rPr>
-              <a:t>chain-of-thought · key · arbitrary URL</a:t>
+              <a:t>결제 키 · 임의 URL · 임의 자산</a:t>
             </a:r>
             <a:endParaRPr lang="en-US" sz="1200" dirty="0"/>
           </a:p>
@@ -4941,7 +4958,7 @@
                 <a:ea typeface="Noto Sans KR" pitchFamily="34" charset="-122"/>
                 <a:cs typeface="Noto Sans KR" pitchFamily="34" charset="-120"/>
               </a:rPr>
-              <a:t>채팅창 대신, 구매 결정을 읽는 조달 데스크.</a:t>
+              <a:t>목표·예산·선택 이유·영수증을 한 흐름에서 확인합니다.</a:t>
             </a:r>
             <a:endParaRPr lang="en-US" sz="2700" dirty="0"/>
           </a:p>
@@ -4980,7 +4997,7 @@
                 <a:ea typeface="Noto Sans KR" pitchFamily="34" charset="-122"/>
                 <a:cs typeface="Noto Sans KR" pitchFamily="34" charset="-120"/>
               </a:rPr>
-              <a:t>Cloud Run live run — Gemini 선택, 정책 승인, Devnet 결제, 영수증을 한 화면에</a:t>
+              <a:t>Cloud Run 실행 — Gemini 선택, 정책 검사, Devnet 결제, 영수증</a:t>
             </a:r>
             <a:endParaRPr lang="en-US" sz="1150" dirty="0"/>
           </a:p>
@@ -5172,7 +5189,7 @@
                 <a:ea typeface="Noto Sans KR" pitchFamily="34" charset="-122"/>
                 <a:cs typeface="Noto Sans KR" pitchFamily="34" charset="-120"/>
               </a:rPr>
-              <a:t>Timeline first</a:t>
+              <a:t>구매 순서</a:t>
             </a:r>
             <a:endParaRPr lang="en-US" sz="1300" dirty="0"/>
           </a:p>
@@ -5211,7 +5228,7 @@
                 <a:ea typeface="Noto Sans KR" pitchFamily="34" charset="-122"/>
                 <a:cs typeface="Noto Sans KR" pitchFamily="34" charset="-120"/>
               </a:rPr>
-              <a:t>탐색 → 이유 → 정책 → 결제 → 수령을 같은 축에서 확인</a:t>
+              <a:t>탐색 → 선택 이유 → 정책 → 결제 → 수령을 시간순으로 확인</a:t>
             </a:r>
             <a:endParaRPr lang="en-US" sz="920" dirty="0"/>
           </a:p>
@@ -5312,7 +5329,7 @@
                 <a:ea typeface="Noto Sans KR" pitchFamily="34" charset="-122"/>
                 <a:cs typeface="Noto Sans KR" pitchFamily="34" charset="-120"/>
               </a:rPr>
-              <a:t>Spend always visible</a:t>
+              <a:t>예산 고정</a:t>
             </a:r>
             <a:endParaRPr lang="en-US" sz="1300" dirty="0"/>
           </a:p>
@@ -5351,7 +5368,7 @@
                 <a:ea typeface="Noto Sans KR" pitchFamily="34" charset="-122"/>
                 <a:cs typeface="Noto Sans KR" pitchFamily="34" charset="-120"/>
               </a:rPr>
-              <a:t>지출, 남은 상한, 영수증을 decision 옆에 고정</a:t>
+              <a:t>지출, 남은 예산, 영수증을 선택 결과 옆에 배치</a:t>
             </a:r>
             <a:endParaRPr lang="en-US" sz="920" dirty="0"/>
           </a:p>
@@ -5452,7 +5469,7 @@
                 <a:ea typeface="Noto Sans KR" pitchFamily="34" charset="-122"/>
                 <a:cs typeface="Noto Sans KR" pitchFamily="34" charset="-120"/>
               </a:rPr>
-              <a:t>Failure is a state</a:t>
+              <a:t>상태별 복구</a:t>
             </a:r>
             <a:endParaRPr lang="en-US" sz="1300" dirty="0"/>
           </a:p>
@@ -5491,7 +5508,7 @@
                 <a:ea typeface="Noto Sans KR" pitchFamily="34" charset="-122"/>
                 <a:cs typeface="Noto Sans KR" pitchFamily="34" charset="-120"/>
               </a:rPr>
-              <a:t>denied·unavailable·reconciling·timeout을 명시적으로 복구</a:t>
+              <a:t>denied·unavailable·reconciling·timeout별 복구 안내</a:t>
             </a:r>
             <a:endParaRPr lang="en-US" sz="920" dirty="0"/>
           </a:p>
@@ -5812,7 +5829,7 @@
                 <a:ea typeface="Noto Sans KR" pitchFamily="34" charset="-122"/>
                 <a:cs typeface="Noto Sans KR" pitchFamily="34" charset="-120"/>
               </a:rPr>
-              <a:t>Cloud Run이 UI·agent API·paid data API를 소유하고, 키는 Secret Manager에만 존재</a:t>
+              <a:t>UI·에이전트 API·유료 데이터 API는 Cloud Run에 두고, 키는 Secret Manager에서만 불러옵니다.</a:t>
             </a:r>
             <a:endParaRPr lang="en-US" sz="1150" dirty="0"/>
           </a:p>
@@ -6879,7 +6896,7 @@
                 <a:ea typeface="Noto Sans KR" pitchFamily="34" charset="-122"/>
                 <a:cs typeface="Noto Sans KR" pitchFamily="34" charset="-120"/>
               </a:rPr>
-              <a:t>CoinGecko + GitHub → snapshotId 고정 → 결제 후 동일 payload 반환</a:t>
+              <a:t>CoinGecko + GitHub → snapshotId 고정 → 결제 후 같은 데이터 반환</a:t>
             </a:r>
             <a:endParaRPr lang="en-US" sz="1150" dirty="0"/>
           </a:p>
@@ -7161,7 +7178,7 @@
                 <a:ea typeface="Noto Sans KR" pitchFamily="34" charset="-122"/>
                 <a:cs typeface="Noto Sans KR" pitchFamily="34" charset="-120"/>
               </a:rPr>
-              <a:t>안전은 프롬프트가 아니라 불변식으로 구현했습니다.</a:t>
+              <a:t>주소·네트워크·자산·예산은 코드가 결제 전에 검증합니다.</a:t>
             </a:r>
             <a:endParaRPr lang="en-US" sz="2700" dirty="0"/>
           </a:p>
@@ -7200,7 +7217,7 @@
                 <a:ea typeface="Noto Sans KR" pitchFamily="34" charset="-122"/>
                 <a:cs typeface="Noto Sans KR" pitchFamily="34" charset="-120"/>
               </a:rPr>
-              <a:t>모델 제안은 hypothesis, 결제 정책은 code-owned contract</a:t>
+              <a:t>Gemini는 상품을 제안하고, 결제 허용 여부는 정책 엔진이 결정합니다.</a:t>
             </a:r>
             <a:endParaRPr lang="en-US" sz="1150" dirty="0"/>
           </a:p>
@@ -7301,7 +7318,7 @@
                 <a:ea typeface="Noto Sans KR" pitchFamily="34" charset="-122"/>
                 <a:cs typeface="Noto Sans KR" pitchFamily="34" charset="-120"/>
               </a:rPr>
-              <a:t>2 products only</a:t>
+              <a:t>상품 2개 고정</a:t>
             </a:r>
             <a:endParaRPr lang="en-US" sz="1300" dirty="0"/>
           </a:p>
@@ -7340,7 +7357,7 @@
                 <a:ea typeface="Noto Sans KR" pitchFamily="34" charset="-122"/>
                 <a:cs typeface="Noto Sans KR" pitchFamily="34" charset="-120"/>
               </a:rPr>
-              <a:t>모델은 URL·network·mint·payee·price를 만들 수 없음</a:t>
+              <a:t>URL·network·mint·payee·price는 카탈로그 값만 허용</a:t>
             </a:r>
             <a:endParaRPr lang="en-US" sz="880" dirty="0"/>
           </a:p>
@@ -7441,7 +7458,7 @@
                 <a:ea typeface="Noto Sans KR" pitchFamily="34" charset="-122"/>
                 <a:cs typeface="Noto Sans KR" pitchFamily="34" charset="-120"/>
               </a:rPr>
-              <a:t>BigInt money</a:t>
+              <a:t>금액은 BigInt</a:t>
             </a:r>
             <a:endParaRPr lang="en-US" sz="1300" dirty="0"/>
           </a:p>
@@ -7480,7 +7497,7 @@
                 <a:ea typeface="Noto Sans KR" pitchFamily="34" charset="-122"/>
                 <a:cs typeface="Noto Sans KR" pitchFamily="34" charset="-120"/>
               </a:rPr>
-              <a:t>6자리 atomic string, purchase 4000 / run 10000 / daily 250000</a:t>
+              <a:t>6자리 atomic 문자열, 구매 4000 / 실행 10000 / 일일 250000</a:t>
             </a:r>
             <a:endParaRPr lang="en-US" sz="880" dirty="0"/>
           </a:p>
@@ -7581,7 +7598,7 @@
                 <a:ea typeface="Noto Sans KR" pitchFamily="34" charset="-122"/>
                 <a:cs typeface="Noto Sans KR" pitchFamily="34" charset="-120"/>
               </a:rPr>
-              <a:t>One payment fingerprint</a:t>
+              <a:t>요청별 결제 ID</a:t>
             </a:r>
             <a:endParaRPr lang="en-US" sz="1300" dirty="0"/>
           </a:p>
@@ -7620,7 +7637,7 @@
                 <a:ea typeface="Noto Sans KR" pitchFamily="34" charset="-122"/>
                 <a:cs typeface="Noto Sans KR" pitchFamily="34" charset="-120"/>
               </a:rPr>
-              <a:t>payment ID가 다른 요청에 재사용되면 transaction에서 거부</a:t>
+              <a:t>같은 payment ID가 다른 요청에 쓰이면 Firestore에서 거부</a:t>
             </a:r>
             <a:endParaRPr lang="en-US" sz="880" dirty="0"/>
           </a:p>
@@ -7721,7 +7738,7 @@
                 <a:ea typeface="Noto Sans KR" pitchFamily="34" charset="-122"/>
                 <a:cs typeface="Noto Sans KR" pitchFamily="34" charset="-120"/>
               </a:rPr>
-              <a:t>No blind retry</a:t>
+              <a:t>자동 재결제 금지</a:t>
             </a:r>
             <a:endParaRPr lang="en-US" sz="1300" dirty="0"/>
           </a:p>
@@ -7760,7 +7777,7 @@
                 <a:ea typeface="Noto Sans KR" pitchFamily="34" charset="-122"/>
                 <a:cs typeface="Noto Sans KR" pitchFamily="34" charset="-120"/>
               </a:rPr>
-              <a:t>서명 후 상태 불명은 reservation을 유지하고 Explorer 확인</a:t>
+              <a:t>서명 뒤 상태가 불명확하면 예약을 유지하고 Explorer에서 확인</a:t>
             </a:r>
             <a:endParaRPr lang="en-US" sz="880" dirty="0"/>
           </a:p>
@@ -7861,7 +7878,7 @@
                 <a:ea typeface="Noto Sans KR" pitchFamily="34" charset="-122"/>
                 <a:cs typeface="Noto Sans KR" pitchFamily="34" charset="-120"/>
               </a:rPr>
-              <a:t>Server-side signer</a:t>
+              <a:t>서버 전용 서명 키</a:t>
             </a:r>
             <a:endParaRPr lang="en-US" sz="1300" dirty="0"/>
           </a:p>
@@ -7900,7 +7917,7 @@
                 <a:ea typeface="Noto Sans KR" pitchFamily="34" charset="-122"/>
                 <a:cs typeface="Noto Sans KR" pitchFamily="34" charset="-120"/>
               </a:rPr>
-              <a:t>키는 Secret Manager → Cloud Run에만 주입, Gemini·브라우저에는 없음</a:t>
+              <a:t>키는 Cloud Run에만 주입하며 Gemini·브라우저에는 전달하지 않음</a:t>
             </a:r>
             <a:endParaRPr lang="en-US" sz="880" dirty="0"/>
           </a:p>
@@ -8001,7 +8018,7 @@
                 <a:ea typeface="Noto Sans KR" pitchFamily="34" charset="-122"/>
                 <a:cs typeface="Noto Sans KR" pitchFamily="34" charset="-120"/>
               </a:rPr>
-              <a:t>Untrusted evidence</a:t>
+              <a:t>외부 데이터는 비신뢰 입력</a:t>
             </a:r>
             <a:endParaRPr lang="en-US" sz="1300" dirty="0"/>
           </a:p>
@@ -8040,7 +8057,7 @@
                 <a:ea typeface="Noto Sans KR" pitchFamily="34" charset="-122"/>
                 <a:cs typeface="Noto Sans KR" pitchFamily="34" charset="-120"/>
               </a:rPr>
-              <a:t>숫자 중심 normalization, catalog/data 안의 지시는 무시</a:t>
+              <a:t>카탈로그와 데이터 속 지시는 무시하고 허용된 숫자 필드만 사용</a:t>
             </a:r>
             <a:endParaRPr lang="en-US" sz="880" dirty="0"/>
           </a:p>
@@ -8129,7 +8146,7 @@
                 <a:ea typeface="Cascadia Mono" pitchFamily="34" charset="-122"/>
                 <a:cs typeface="Cascadia Mono" pitchFamily="34" charset="-120"/>
               </a:rPr>
-              <a:t>MVP excludes</a:t>
+              <a:t>제외 범위</a:t>
             </a:r>
             <a:endParaRPr lang="en-US" sz="700" dirty="0"/>
           </a:p>
@@ -8168,7 +8185,7 @@
                 <a:ea typeface="Noto Sans KR" pitchFamily="34" charset="-122"/>
                 <a:cs typeface="Noto Sans KR" pitchFamily="34" charset="-120"/>
               </a:rPr>
-              <a:t>mainnet · real funds · arbitrary seller · login · subscription · multi-agent</a:t>
+              <a:t>Mainnet · 실자산 · 임의 판매자 · 로그인 · 구독 · 멀티에이전트</a:t>
             </a:r>
             <a:endParaRPr lang="en-US" sz="1050" dirty="0"/>
           </a:p>
@@ -8450,7 +8467,7 @@
                 <a:ea typeface="Noto Sans KR" pitchFamily="34" charset="-122"/>
                 <a:cs typeface="Noto Sans KR" pitchFamily="34" charset="-120"/>
               </a:rPr>
-              <a:t>두 번의 구매, 두 개의 공개 영수증.</a:t>
+              <a:t>구매 2건과 Explorer 영수증 2건.</a:t>
             </a:r>
             <a:endParaRPr lang="en-US" sz="2700" dirty="0"/>
           </a:p>
@@ -9373,7 +9390,7 @@
                 <a:ea typeface="Noto Sans KR" pitchFamily="34" charset="-122"/>
                 <a:cs typeface="Noto Sans KR" pitchFamily="34" charset="-120"/>
               </a:rPr>
-              <a:t>Explorer에서 network·mint·payee·amount를 검증했습니다.</a:t>
+              <a:t>Explorer와 RPC에서 네트워크·자산·수취 주소·금액을 확인했습니다.</a:t>
             </a:r>
             <a:endParaRPr lang="en-US" sz="1070" dirty="0"/>
           </a:p>
@@ -9655,7 +9672,7 @@
                 <a:ea typeface="Noto Sans KR" pitchFamily="34" charset="-122"/>
                 <a:cs typeface="Noto Sans KR" pitchFamily="34" charset="-120"/>
               </a:rPr>
-              <a:t>에이전트 커머스의 다음 UX는</a:t>
+              <a:t>구매 결과에는 선택 이유, 정책 판단,</a:t>
             </a:r>
             <a:endParaRPr lang="en-US" sz="3100" dirty="0"/>
           </a:p>
@@ -9672,7 +9689,7 @@
                 <a:ea typeface="Noto Sans KR" pitchFamily="34" charset="-122"/>
                 <a:cs typeface="Noto Sans KR" pitchFamily="34" charset="-120"/>
               </a:rPr>
-              <a:t>‘살 수 있음’이 아니라 ‘증명 가능한 구매’입니다.</a:t>
+              <a:t>거래 영수증이 함께 남아야 합니다.</a:t>
             </a:r>
             <a:endParaRPr lang="en-US" sz="3100" dirty="0"/>
           </a:p>
@@ -9711,7 +9728,7 @@
                 <a:ea typeface="Noto Sans KR" pitchFamily="34" charset="-122"/>
                 <a:cs typeface="Noto Sans KR" pitchFamily="34" charset="-120"/>
               </a:rPr>
-              <a:t>REIN은 작은 고정 카탈로그에서 시작하지만, 같은 contract를 리서치 API, B2B 데이터, 모델·툴 조달로 확장할 수 있습니다.</a:t>
+              <a:t>지금은 데이터 상품 2개를 다룹니다. 같은 결제 계약을 리서치 API, B2B 데이터, 모델·도구 구매에도 적용할 수 있습니다.</a:t>
             </a:r>
             <a:endParaRPr lang="en-US" sz="1300" dirty="0"/>
           </a:p>

</xml_diff>

<commit_message>
Clarify autonomous settlement experience
</commit_message>
<xml_diff>
--- a/output/presentation/REIN-Hackathon-Deck.pptx
+++ b/output/presentation/REIN-Hackathon-Deck.pptx
@@ -1722,7 +1722,7 @@
                 <a:ea typeface="Cascadia Mono" pitchFamily="34" charset="-122"/>
                 <a:cs typeface="Cascadia Mono" pitchFamily="34" charset="-120"/>
               </a:rPr>
-              <a:t>AGENT-INITIATED COMMERCE</a:t>
+              <a:t>SOLANA AGENTIC COMMERCE</a:t>
             </a:r>
             <a:endParaRPr lang="en-US" sz="900" dirty="0"/>
           </a:p>
@@ -1817,7 +1817,7 @@
                 <a:ea typeface="Noto Sans KR" pitchFamily="34" charset="-122"/>
                 <a:cs typeface="Noto Sans KR" pitchFamily="34" charset="-120"/>
               </a:rPr>
-              <a:t>목표와 예산을 받으면 데이터를 고르고, 결제한 뒤 근거와 영수증을 남깁니다.</a:t>
+              <a:t>목표와 예산만 정하면, REIN 전용 지갑이 데이터 구매까지 끝냅니다.</a:t>
             </a:r>
             <a:endParaRPr lang="en-US" sz="1500" dirty="0"/>
           </a:p>
@@ -2126,7 +2126,46 @@
       </p:sp>
       <p:sp>
         <p:nvSpPr>
-          <p:cNvPr id="15" name="Shape 12"/>
+          <p:cNvPr id="15" name="Text 12"/>
+          <p:cNvSpPr/>
+          <p:nvPr/>
+        </p:nvSpPr>
+        <p:spPr>
+          <a:xfrm>
+            <a:off x="8247888" y="4864608"/>
+            <a:ext cx="2560320" cy="182880"/>
+          </a:xfrm>
+          <a:prstGeom prst="rect">
+            <a:avLst/>
+          </a:prstGeom>
+          <a:noFill/>
+          <a:ln/>
+        </p:spPr>
+        <p:txBody>
+          <a:bodyPr wrap="square" lIns="0" tIns="0" rIns="0" bIns="0" rtlCol="0" anchor="ctr"/>
+          <a:lstStyle/>
+          <a:p>
+            <a:pPr indent="0" marL="0">
+              <a:buNone/>
+            </a:pPr>
+            <a:r>
+              <a:rPr lang="en-US" sz="700" b="1" dirty="0">
+                <a:solidFill>
+                  <a:srgbClr val="DDEBE5"/>
+                </a:solidFill>
+                <a:latin typeface="Cascadia Mono" pitchFamily="34" charset="0"/>
+                <a:ea typeface="Cascadia Mono" pitchFamily="34" charset="-122"/>
+                <a:cs typeface="Cascadia Mono" pitchFamily="34" charset="-120"/>
+              </a:rPr>
+              <a:t>POLICY-GATED SERVER WALLET</a:t>
+            </a:r>
+            <a:endParaRPr lang="en-US" sz="700" dirty="0"/>
+          </a:p>
+        </p:txBody>
+      </p:sp>
+      <p:sp>
+        <p:nvSpPr>
+          <p:cNvPr id="16" name="Shape 13"/>
           <p:cNvSpPr/>
           <p:nvPr/>
         </p:nvSpPr>
@@ -2149,7 +2188,7 @@
       </p:sp>
       <p:sp>
         <p:nvSpPr>
-          <p:cNvPr id="16" name="Text 13"/>
+          <p:cNvPr id="17" name="Text 14"/>
           <p:cNvSpPr/>
           <p:nvPr/>
         </p:nvSpPr>
@@ -2400,7 +2439,7 @@
                 <a:ea typeface="Noto Sans KR" pitchFamily="34" charset="-122"/>
                 <a:cs typeface="Noto Sans KR" pitchFamily="34" charset="-120"/>
               </a:rPr>
-              <a:t>데이터를 고르는 모델에게 결제 권한까지 맡길 수는 없습니다.</a:t>
+              <a:t>모델이 데이터를 골라도, 지갑과 예산은 코드가 통제해야 합니다.</a:t>
             </a:r>
             <a:endParaRPr lang="en-US" sz="2700" dirty="0"/>
           </a:p>
@@ -4258,7 +4297,7 @@
                 <a:ea typeface="Noto Sans KR" pitchFamily="34" charset="-122"/>
                 <a:cs typeface="Noto Sans KR" pitchFamily="34" charset="-120"/>
               </a:rPr>
-              <a:t>x402 결제</a:t>
+              <a:t>서버 지갑 결제</a:t>
             </a:r>
             <a:endParaRPr lang="en-US" sz="1500" dirty="0"/>
           </a:p>
@@ -4297,7 +4336,7 @@
                 <a:ea typeface="Noto Sans KR" pitchFamily="34" charset="-122"/>
                 <a:cs typeface="Noto Sans KR" pitchFamily="34" charset="-120"/>
               </a:rPr>
-              <a:t>Devnet USDC</a:t>
+              <a:t>x402 · Devnet USDC</a:t>
             </a:r>
             <a:endParaRPr lang="en-US" sz="950" dirty="0"/>
           </a:p>
@@ -5036,7 +5075,7 @@
         </p:nvPicPr>
         <p:blipFill>
           <a:blip r:embed="rId3"/>
-          <a:srcRect l="0" r="0" t="8916" b="8916"/>
+          <a:srcRect l="0" r="0" t="39220" b="39220"/>
           <a:stretch/>
         </p:blipFill>
         <p:spPr>
@@ -5329,7 +5368,7 @@
                 <a:ea typeface="Noto Sans KR" pitchFamily="34" charset="-122"/>
                 <a:cs typeface="Noto Sans KR" pitchFamily="34" charset="-120"/>
               </a:rPr>
-              <a:t>예산 고정</a:t>
+              <a:t>지갑 역할</a:t>
             </a:r>
             <a:endParaRPr lang="en-US" sz="1300" dirty="0"/>
           </a:p>
@@ -5368,7 +5407,7 @@
                 <a:ea typeface="Noto Sans KR" pitchFamily="34" charset="-122"/>
                 <a:cs typeface="Noto Sans KR" pitchFamily="34" charset="-120"/>
               </a:rPr>
-              <a:t>지출, 남은 예산, 영수증을 선택 결과 옆에 배치</a:t>
+              <a:t>REIN 에이전트 지갑과 데이터 판매자 주소를 영수증에 표시</a:t>
             </a:r>
             <a:endParaRPr lang="en-US" sz="920" dirty="0"/>
           </a:p>
@@ -6615,7 +6654,7 @@
                 <a:ea typeface="Noto Sans KR" pitchFamily="34" charset="-122"/>
                 <a:cs typeface="Noto Sans KR" pitchFamily="34" charset="-120"/>
               </a:rPr>
-              <a:t>buyer + protected seller</a:t>
+              <a:t>server buyer wallet + seller</a:t>
             </a:r>
             <a:endParaRPr lang="en-US" sz="900" dirty="0"/>
           </a:p>
@@ -7878,7 +7917,7 @@
                 <a:ea typeface="Noto Sans KR" pitchFamily="34" charset="-122"/>
                 <a:cs typeface="Noto Sans KR" pitchFamily="34" charset="-120"/>
               </a:rPr>
-              <a:t>서버 전용 서명 키</a:t>
+              <a:t>에이전트 서버 지갑</a:t>
             </a:r>
             <a:endParaRPr lang="en-US" sz="1300" dirty="0"/>
           </a:p>
@@ -7917,7 +7956,7 @@
                 <a:ea typeface="Noto Sans KR" pitchFamily="34" charset="-122"/>
                 <a:cs typeface="Noto Sans KR" pitchFamily="34" charset="-120"/>
               </a:rPr>
-              <a:t>키는 Cloud Run에만 주입하며 Gemini·브라우저에는 전달하지 않음</a:t>
+              <a:t>Secret Manager 키로 정책 승인 결제만 서명하며 브라우저 연결은 사용하지 않음</a:t>
             </a:r>
             <a:endParaRPr lang="en-US" sz="880" dirty="0"/>
           </a:p>
@@ -9703,40 +9742,118 @@
         </p:nvSpPr>
         <p:spPr>
           <a:xfrm>
-            <a:off x="694944" y="3429000"/>
-            <a:ext cx="6583680" cy="731520"/>
-          </a:xfrm>
-          <a:prstGeom prst="rect">
-            <a:avLst/>
-          </a:prstGeom>
-          <a:noFill/>
-          <a:ln/>
-        </p:spPr>
-        <p:txBody>
-          <a:bodyPr wrap="square" lIns="0" tIns="0" rIns="0" bIns="0" rtlCol="0" anchor="t"/>
-          <a:lstStyle/>
-          <a:p>
-            <a:pPr indent="0" marL="0">
-              <a:buNone/>
-            </a:pPr>
-            <a:r>
-              <a:rPr lang="en-US" sz="1300" dirty="0">
-                <a:solidFill>
-                  <a:srgbClr val="52645D"/>
+            <a:off x="694944" y="3236976"/>
+            <a:ext cx="3931920" cy="182880"/>
+          </a:xfrm>
+          <a:prstGeom prst="rect">
+            <a:avLst/>
+          </a:prstGeom>
+          <a:noFill/>
+          <a:ln/>
+        </p:spPr>
+        <p:txBody>
+          <a:bodyPr wrap="square" lIns="0" tIns="0" rIns="0" bIns="0" rtlCol="0" anchor="ctr"/>
+          <a:lstStyle/>
+          <a:p>
+            <a:pPr indent="0" marL="0">
+              <a:buNone/>
+            </a:pPr>
+            <a:r>
+              <a:rPr lang="en-US" sz="750" b="1" dirty="0">
+                <a:solidFill>
+                  <a:srgbClr val="08664B"/>
+                </a:solidFill>
+                <a:latin typeface="Cascadia Mono" pitchFamily="34" charset="0"/>
+                <a:ea typeface="Cascadia Mono" pitchFamily="34" charset="-122"/>
+                <a:cs typeface="Cascadia Mono" pitchFamily="34" charset="-120"/>
+              </a:rPr>
+              <a:t>SOLANA AGENTIC COMMERCE / SINGLE TRACK</a:t>
+            </a:r>
+            <a:endParaRPr lang="en-US" sz="750" dirty="0"/>
+          </a:p>
+        </p:txBody>
+      </p:sp>
+      <p:sp>
+        <p:nvSpPr>
+          <p:cNvPr id="7" name="Text 4"/>
+          <p:cNvSpPr/>
+          <p:nvPr/>
+        </p:nvSpPr>
+        <p:spPr>
+          <a:xfrm>
+            <a:off x="694944" y="3493008"/>
+            <a:ext cx="6583680" cy="256032"/>
+          </a:xfrm>
+          <a:prstGeom prst="rect">
+            <a:avLst/>
+          </a:prstGeom>
+          <a:noFill/>
+          <a:ln/>
+        </p:spPr>
+        <p:txBody>
+          <a:bodyPr wrap="square" lIns="0" tIns="0" rIns="0" bIns="0" rtlCol="0" anchor="ctr"/>
+          <a:lstStyle/>
+          <a:p>
+            <a:pPr indent="0" marL="0">
+              <a:buNone/>
+            </a:pPr>
+            <a:r>
+              <a:rPr lang="en-US" sz="1250" b="1" dirty="0">
+                <a:solidFill>
+                  <a:srgbClr val="111A16"/>
                 </a:solidFill>
                 <a:latin typeface="Noto Sans KR" pitchFamily="34" charset="0"/>
                 <a:ea typeface="Noto Sans KR" pitchFamily="34" charset="-122"/>
                 <a:cs typeface="Noto Sans KR" pitchFamily="34" charset="-120"/>
               </a:rPr>
-              <a:t>지금은 데이터 상품 2개를 다룹니다. 같은 결제 계약을 리서치 API, B2B 데이터, 모델·도구 구매에도 적용할 수 있습니다.</a:t>
-            </a:r>
-            <a:endParaRPr lang="en-US" sz="1300" dirty="0"/>
-          </a:p>
-        </p:txBody>
-      </p:sp>
-      <p:sp>
-        <p:nvSpPr>
-          <p:cNvPr id="7" name="Shape 4"/>
+              <a:t>가장 가까운 시작점: B. Autonomous On-chain Settlement</a:t>
+            </a:r>
+            <a:endParaRPr lang="en-US" sz="1250" dirty="0"/>
+          </a:p>
+        </p:txBody>
+      </p:sp>
+      <p:sp>
+        <p:nvSpPr>
+          <p:cNvPr id="8" name="Text 5"/>
+          <p:cNvSpPr/>
+          <p:nvPr/>
+        </p:nvSpPr>
+        <p:spPr>
+          <a:xfrm>
+            <a:off x="694944" y="3913632"/>
+            <a:ext cx="6583680" cy="658368"/>
+          </a:xfrm>
+          <a:prstGeom prst="rect">
+            <a:avLst/>
+          </a:prstGeom>
+          <a:noFill/>
+          <a:ln/>
+        </p:spPr>
+        <p:txBody>
+          <a:bodyPr wrap="square" lIns="0" tIns="0" rIns="0" bIns="0" rtlCol="0" anchor="t"/>
+          <a:lstStyle/>
+          <a:p>
+            <a:pPr indent="0" marL="0">
+              <a:buNone/>
+            </a:pPr>
+            <a:r>
+              <a:rPr lang="en-US" sz="1200" dirty="0">
+                <a:solidFill>
+                  <a:srgbClr val="52645D"/>
+                </a:solidFill>
+                <a:latin typeface="Noto Sans KR" pitchFamily="34" charset="0"/>
+                <a:ea typeface="Noto Sans KR" pitchFamily="34" charset="-122"/>
+                <a:cs typeface="Noto Sans KR" pitchFamily="34" charset="-120"/>
+              </a:rPr>
+              <a:t>지금은 데이터 상품 2개를 다룹니다. 같은 결제 계약을 유료 리서치 API, B2B 데이터, 모델·도구 구매에도 적용할 수 있습니다.</a:t>
+            </a:r>
+            <a:endParaRPr lang="en-US" sz="1200" dirty="0"/>
+          </a:p>
+        </p:txBody>
+      </p:sp>
+      <p:sp>
+        <p:nvSpPr>
+          <p:cNvPr id="9" name="Shape 6"/>
           <p:cNvSpPr/>
           <p:nvPr/>
         </p:nvSpPr>
@@ -9763,7 +9880,7 @@
       </p:sp>
       <p:sp>
         <p:nvSpPr>
-          <p:cNvPr id="8" name="Text 5"/>
+          <p:cNvPr id="10" name="Text 7"/>
           <p:cNvSpPr/>
           <p:nvPr/>
         </p:nvSpPr>
@@ -9802,7 +9919,7 @@
       </p:sp>
       <p:sp>
         <p:nvSpPr>
-          <p:cNvPr id="9" name="Text 6"/>
+          <p:cNvPr id="11" name="Text 8"/>
           <p:cNvSpPr/>
           <p:nvPr/>
         </p:nvSpPr>
@@ -9841,7 +9958,7 @@
       </p:sp>
       <p:sp>
         <p:nvSpPr>
-          <p:cNvPr id="10" name="Text 7"/>
+          <p:cNvPr id="12" name="Text 9"/>
           <p:cNvSpPr/>
           <p:nvPr/>
         </p:nvSpPr>
@@ -9880,7 +9997,7 @@
       </p:sp>
       <p:sp>
         <p:nvSpPr>
-          <p:cNvPr id="11" name="Shape 8"/>
+          <p:cNvPr id="13" name="Shape 10"/>
           <p:cNvSpPr/>
           <p:nvPr/>
         </p:nvSpPr>
@@ -9903,7 +10020,7 @@
       </p:sp>
       <p:sp>
         <p:nvSpPr>
-          <p:cNvPr id="12" name="Text 9"/>
+          <p:cNvPr id="14" name="Text 11"/>
           <p:cNvSpPr/>
           <p:nvPr/>
         </p:nvSpPr>
@@ -9942,7 +10059,7 @@
       </p:sp>
       <p:sp>
         <p:nvSpPr>
-          <p:cNvPr id="13" name="Text 10"/>
+          <p:cNvPr id="15" name="Text 12"/>
           <p:cNvSpPr/>
           <p:nvPr/>
         </p:nvSpPr>
@@ -9981,7 +10098,7 @@
       </p:sp>
       <p:sp>
         <p:nvSpPr>
-          <p:cNvPr id="14" name="Shape 11"/>
+          <p:cNvPr id="16" name="Shape 13"/>
           <p:cNvSpPr/>
           <p:nvPr/>
         </p:nvSpPr>
@@ -10004,7 +10121,7 @@
       </p:sp>
       <p:sp>
         <p:nvSpPr>
-          <p:cNvPr id="15" name="Text 12"/>
+          <p:cNvPr id="17" name="Text 14"/>
           <p:cNvSpPr/>
           <p:nvPr/>
         </p:nvSpPr>
@@ -10043,7 +10160,7 @@
       </p:sp>
       <p:sp>
         <p:nvSpPr>
-          <p:cNvPr id="16" name="Text 13"/>
+          <p:cNvPr id="18" name="Text 15"/>
           <p:cNvSpPr/>
           <p:nvPr/>
         </p:nvSpPr>
@@ -10082,7 +10199,7 @@
       </p:sp>
       <p:sp>
         <p:nvSpPr>
-          <p:cNvPr id="17" name="Text 14"/>
+          <p:cNvPr id="19" name="Text 16"/>
           <p:cNvSpPr/>
           <p:nvPr/>
         </p:nvSpPr>
@@ -10113,7 +10230,7 @@
                 <a:ea typeface="Noto Sans KR" pitchFamily="34" charset="-122"/>
                 <a:cs typeface="Noto Sans KR" pitchFamily="34" charset="-120"/>
               </a:rPr>
-              <a:t>Autonomy, held to proof.</a:t>
+              <a:t>사람은 한도를 정하고, 에이전트는 결제를 끝냅니다.</a:t>
             </a:r>
             <a:endParaRPr lang="en-US" sz="1800" dirty="0"/>
           </a:p>
@@ -10121,7 +10238,7 @@
       </p:sp>
       <p:sp>
         <p:nvSpPr>
-          <p:cNvPr id="18" name="Shape 15"/>
+          <p:cNvPr id="20" name="Shape 17"/>
           <p:cNvSpPr/>
           <p:nvPr/>
         </p:nvSpPr>
@@ -10144,7 +10261,7 @@
       </p:sp>
       <p:sp>
         <p:nvSpPr>
-          <p:cNvPr id="19" name="Text 16"/>
+          <p:cNvPr id="21" name="Text 18"/>
           <p:cNvSpPr/>
           <p:nvPr/>
         </p:nvSpPr>
@@ -10175,7 +10292,7 @@
                 <a:ea typeface="Cascadia Mono" pitchFamily="34" charset="-122"/>
                 <a:cs typeface="Cascadia Mono" pitchFamily="34" charset="-120"/>
               </a:rPr>
-              <a:t>REIN / AGENT-INITIATED COMMERCE</a:t>
+              <a:t>REIN / SOLANA AGENTIC COMMERCE</a:t>
             </a:r>
             <a:endParaRPr lang="en-US" sz="680" dirty="0"/>
           </a:p>

</xml_diff>

<commit_message>
Remove submission workflow from public surfaces
</commit_message>
<xml_diff>
--- a/output/presentation/REIN-Hackathon-Deck.pptx
+++ b/output/presentation/REIN-Hackathon-Deck.pptx
@@ -9911,7 +9911,7 @@
                 <a:ea typeface="Cascadia Mono" pitchFamily="34" charset="-122"/>
                 <a:cs typeface="Cascadia Mono" pitchFamily="34" charset="-120"/>
               </a:rPr>
-              <a:t>SUBMISSION</a:t>
+              <a:t>VERIFY</a:t>
             </a:r>
             <a:endParaRPr lang="en-US" sz="800" dirty="0"/>
           </a:p>
@@ -10152,7 +10152,7 @@
                 <a:ea typeface="Noto Sans KR" pitchFamily="34" charset="-122"/>
                 <a:cs typeface="Noto Sans KR" pitchFamily="34" charset="-120"/>
               </a:rPr>
-              <a:t>Video demo</a:t>
+              <a:t>Devnet receipts</a:t>
             </a:r>
             <a:endParaRPr lang="en-US" sz="1300" dirty="0"/>
           </a:p>
@@ -10191,7 +10191,7 @@
                 <a:ea typeface="Cascadia Mono" pitchFamily="34" charset="-122"/>
                 <a:cs typeface="Cascadia Mono" pitchFamily="34" charset="-120"/>
               </a:rPr>
-              <a:t>≤ 3 min · captions included</a:t>
+              <a:t>02 finalized transactions</a:t>
             </a:r>
             <a:endParaRPr lang="en-US" sz="720" dirty="0"/>
           </a:p>

</xml_diff>